<commit_message>
Adiciona ilustrações unDraw à apresentação do diagnóstico
Co-Authored-By: Claude Opus 5.5 <noreply@anthropic.com>
Claude-Session: https://claude.ai/code/session_01CGybLKKyqEcaRdUvuV6nEG
</commit_message>
<xml_diff>
--- a/Diagnostico_Arquitetura_Dados_MEC_AS_IS.pptx
+++ b/Diagnostico_Arquitetura_Dados_MEC_AS_IS.pptx
@@ -124,20 +124,20 @@
   <p:extLst>
     <p:ext uri="{521415D9-36F7-43E2-AB2F-B90AF26B5E84}">
       <p14:sectionLst xmlns:p14="http://schemas.microsoft.com/office/powerpoint/2010/main">
-        <p14:section name="Abertura" id="{98ba23de-ffb1-be18-1334-22acdf770757}">
+        <p14:section name="Abertura" id="{c0382b9f-1fc3-bcb3-6f1d-677aff2e704f}">
           <p14:sldIdLst>
             <p14:sldId id="256"/>
             <p14:sldId id="257"/>
             <p14:sldId id="258"/>
           </p14:sldIdLst>
         </p14:section>
-        <p14:section name="Contexto" id="{f556cba2-6405-028a-78cb-d151e5262e97}">
+        <p14:section name="Contexto" id="{64872d34-914a-da4e-b661-ad2d8b754ebd}">
           <p14:sldIdLst>
             <p14:sldId id="259"/>
             <p14:sldId id="260"/>
           </p14:sldIdLst>
         </p14:section>
-        <p14:section name="Arquitetura (AS IS)" id="{3d13a371-e147-2001-ccb0-76769724a18b}">
+        <p14:section name="Arquitetura (AS IS)" id="{f3315995-6978-8086-d810-7d4b9758e869}">
           <p14:sldIdLst>
             <p14:sldId id="261"/>
             <p14:sldId id="262"/>
@@ -148,13 +148,13 @@
             <p14:sldId id="267"/>
           </p14:sldIdLst>
         </p14:section>
-        <p14:section name="Governança e tecnologias" id="{befe8142-c025-3569-1c30-8490f69f4cd4}">
+        <p14:section name="Governança e tecnologias" id="{477861e7-6629-296f-8702-a0378227c16c}">
           <p14:sldIdLst>
             <p14:sldId id="268"/>
             <p14:sldId id="269"/>
           </p14:sldIdLst>
         </p14:section>
-        <p14:section name="Situação e próximos passos" id="{6159f746-26a0-1b61-fd14-d7f27cd3fe0c}">
+        <p14:section name="Situação e próximos passos" id="{c2df2066-26f0-4250-314b-fb2cf43a0550}">
           <p14:sldIdLst>
             <p14:sldId id="270"/>
             <p14:sldId id="271"/>
@@ -2590,8 +2590,8 @@
         </p:nvSpPr>
         <p:spPr>
           <a:xfrm>
-            <a:off x="822960" y="2377440"/>
-            <a:ext cx="8686800" cy="1280160"/>
+            <a:off x="822960" y="2103120"/>
+            <a:ext cx="5943600" cy="1554480"/>
           </a:xfrm>
           <a:prstGeom prst="rect">
             <a:avLst/>
@@ -2630,7 +2630,7 @@
         <p:spPr>
           <a:xfrm>
             <a:off x="822960" y="3749040"/>
-            <a:ext cx="8686800" cy="914400"/>
+            <a:ext cx="5943600" cy="914400"/>
           </a:xfrm>
           <a:prstGeom prst="rect">
             <a:avLst/>
@@ -8566,11 +8566,11 @@
         <p:spPr>
           <a:xfrm>
             <a:off x="6400800" y="1280160"/>
-            <a:ext cx="5029200" cy="4480560"/>
+            <a:ext cx="5029200" cy="3063240"/>
           </a:xfrm>
           <a:prstGeom prst="roundRect">
             <a:avLst>
-              <a:gd name="adj" fmla="val 2449"/>
+              <a:gd name="adj" fmla="val 3582"/>
             </a:avLst>
           </a:prstGeom>
           <a:solidFill>
@@ -8579,16 +8579,40 @@
           <a:ln/>
         </p:spPr>
       </p:sp>
-      <p:sp>
-        <p:nvSpPr>
-          <p:cNvPr id="30" name="Text 23"/>
+      <p:pic>
+        <p:nvPicPr>
+          <p:cNvPr id="30" name="Ilustração secure-server" descr="Ilustração: escudo de segurança protegendo servidores">    </p:cNvPr>
+          <p:cNvPicPr>
+            <a:picLocks noChangeAspect="1"/>
+          </p:cNvPicPr>
+          <p:nvPr/>
+        </p:nvPicPr>
+        <p:blipFill>
+          <a:blip r:embed="rId6"/>
+          <a:stretch>
+            <a:fillRect/>
+          </a:stretch>
+        </p:blipFill>
+        <p:spPr>
+          <a:xfrm>
+            <a:off x="7635240" y="4480560"/>
+            <a:ext cx="2560320" cy="1676699"/>
+          </a:xfrm>
+          <a:prstGeom prst="rect">
+            <a:avLst/>
+          </a:prstGeom>
+        </p:spPr>
+      </p:pic>
+      <p:sp>
+        <p:nvSpPr>
+          <p:cNvPr id="31" name="Text 23"/>
           <p:cNvSpPr txBox="1"/>
           <p:nvPr/>
         </p:nvSpPr>
         <p:spPr>
           <a:xfrm>
-            <a:off x="6720840" y="1508760"/>
-            <a:ext cx="4389120" cy="411480"/>
+            <a:off x="6720840" y="1417320"/>
+            <a:ext cx="4389120" cy="365760"/>
           </a:xfrm>
           <a:prstGeom prst="rect">
             <a:avLst/>
@@ -8604,27 +8628,27 @@
               <a:buNone/>
             </a:pPr>
             <a:r>
-              <a:rPr lang="en-US" sz="1800" b="1" i="1" dirty="0">
+              <a:rPr lang="en-US" sz="1700" b="1" i="1" dirty="0">
                 <a:solidFill>
                   <a:schemeClr val="accent3"/>
                 </a:solidFill>
               </a:rPr>
               <a:t>O que já é possível</a:t>
             </a:r>
-            <a:endParaRPr lang="en-US" sz="1800" dirty="0"/>
-          </a:p>
-        </p:txBody>
-      </p:sp>
-      <p:sp>
-        <p:nvSpPr>
-          <p:cNvPr id="31" name="Text 24"/>
+            <a:endParaRPr lang="en-US" sz="1700" dirty="0"/>
+          </a:p>
+        </p:txBody>
+      </p:sp>
+      <p:sp>
+        <p:nvSpPr>
+          <p:cNvPr id="32" name="Text 24"/>
           <p:cNvSpPr txBox="1"/>
           <p:nvPr/>
         </p:nvSpPr>
         <p:spPr>
           <a:xfrm>
-            <a:off x="6720840" y="1965960"/>
-            <a:ext cx="4389120" cy="1280160"/>
+            <a:off x="6720840" y="1783080"/>
+            <a:ext cx="4389120" cy="868680"/>
           </a:xfrm>
           <a:prstGeom prst="rect">
             <a:avLst/>
@@ -8640,27 +8664,27 @@
               <a:buNone/>
             </a:pPr>
             <a:r>
-              <a:rPr lang="en-US" sz="1500" dirty="0">
+              <a:rPr lang="en-US" sz="1300" dirty="0">
                 <a:solidFill>
                   <a:schemeClr val="bg1"/>
                 </a:solidFill>
               </a:rPr>
               <a:t>Com VPN e acesso ao Oracle DW, a equipe já consegue inspecionar os schemas e os ambientes de banco de dados (DSV, HMG, PRD e Stage).</a:t>
             </a:r>
-            <a:endParaRPr lang="en-US" sz="1500" dirty="0"/>
-          </a:p>
-        </p:txBody>
-      </p:sp>
-      <p:sp>
-        <p:nvSpPr>
-          <p:cNvPr id="32" name="Text 25"/>
+            <a:endParaRPr lang="en-US" sz="1300" dirty="0"/>
+          </a:p>
+        </p:txBody>
+      </p:sp>
+      <p:sp>
+        <p:nvSpPr>
+          <p:cNvPr id="33" name="Text 25"/>
           <p:cNvSpPr txBox="1"/>
           <p:nvPr/>
         </p:nvSpPr>
         <p:spPr>
           <a:xfrm>
-            <a:off x="6720840" y="3383280"/>
-            <a:ext cx="4389120" cy="411480"/>
+            <a:off x="6720840" y="2743200"/>
+            <a:ext cx="4389120" cy="365760"/>
           </a:xfrm>
           <a:prstGeom prst="rect">
             <a:avLst/>
@@ -8676,27 +8700,27 @@
               <a:buNone/>
             </a:pPr>
             <a:r>
-              <a:rPr lang="en-US" sz="1800" b="1" i="1" dirty="0">
+              <a:rPr lang="en-US" sz="1700" b="1" i="1" dirty="0">
                 <a:solidFill>
                   <a:schemeClr val="accent3"/>
                 </a:solidFill>
               </a:rPr>
               <a:t>O que ainda falta</a:t>
             </a:r>
-            <a:endParaRPr lang="en-US" sz="1800" dirty="0"/>
-          </a:p>
-        </p:txBody>
-      </p:sp>
-      <p:sp>
-        <p:nvSpPr>
-          <p:cNvPr id="33" name="Text 26"/>
+            <a:endParaRPr lang="en-US" sz="1700" dirty="0"/>
+          </a:p>
+        </p:txBody>
+      </p:sp>
+      <p:sp>
+        <p:nvSpPr>
+          <p:cNvPr id="34" name="Text 26"/>
           <p:cNvSpPr txBox="1"/>
           <p:nvPr/>
         </p:nvSpPr>
         <p:spPr>
           <a:xfrm>
-            <a:off x="6720840" y="3840480"/>
-            <a:ext cx="4389120" cy="1371600"/>
+            <a:off x="6720840" y="3108960"/>
+            <a:ext cx="4389120" cy="1097280"/>
           </a:xfrm>
           <a:prstGeom prst="rect">
             <a:avLst/>
@@ -8712,14 +8736,14 @@
               <a:buNone/>
             </a:pPr>
             <a:r>
-              <a:rPr lang="en-US" sz="1500" dirty="0">
+              <a:rPr lang="en-US" sz="1300" dirty="0">
                 <a:solidFill>
                   <a:schemeClr val="bg1"/>
                 </a:solidFill>
               </a:rPr>
               <a:t>Integrar-se ao fluxo de versionamento e integração contínua da CGDA/STIC, que depende dos acessos ao GitLab, ao projeto das DAGs e ao GitLab CI.</a:t>
             </a:r>
-            <a:endParaRPr lang="en-US" sz="1500" dirty="0"/>
+            <a:endParaRPr lang="en-US" sz="1300" dirty="0"/>
           </a:p>
         </p:txBody>
       </p:sp>
@@ -9783,7 +9807,7 @@
         <p:spPr>
           <a:xfrm>
             <a:off x="822960" y="1280160"/>
-            <a:ext cx="10607040" cy="4480560"/>
+            <a:ext cx="7406640" cy="4297680"/>
           </a:xfrm>
           <a:prstGeom prst="rect">
             <a:avLst/>
@@ -9797,178 +9821,202 @@
           <a:p>
             <a:pPr indent="0" marL="0">
               <a:spcAft>
-                <a:spcPts val="600"/>
+                <a:spcPts val="500"/>
               </a:spcAft>
               <a:buNone/>
             </a:pPr>
             <a:r>
-              <a:rPr lang="en-US" sz="1300" i="1" dirty="0">
+              <a:rPr lang="en-US" sz="1200" i="1" dirty="0">
                 <a:solidFill>
                   <a:schemeClr val="tx1"/>
                 </a:solidFill>
               </a:rPr>
               <a:t>APACHE AIRFLOW. Apache Airflow Documentation. Disponível em: https://airflow.apache.org/docs/.</a:t>
             </a:r>
-            <a:endParaRPr lang="en-US" sz="1300" dirty="0"/>
+            <a:endParaRPr lang="en-US" sz="1200" dirty="0"/>
           </a:p>
           <a:p>
             <a:pPr indent="0" marL="0">
               <a:spcAft>
-                <a:spcPts val="600"/>
+                <a:spcPts val="500"/>
               </a:spcAft>
               <a:buNone/>
             </a:pPr>
             <a:r>
-              <a:rPr lang="en-US" sz="1300" i="1" dirty="0">
+              <a:rPr lang="en-US" sz="1200" i="1" dirty="0">
                 <a:solidFill>
                   <a:schemeClr val="tx1"/>
                 </a:solidFill>
               </a:rPr>
               <a:t>CGDA. Metodologia de Administração de Dados: Anexo – Modelagem de Dados Dimensional. Brasília: MEC, 2022.</a:t>
             </a:r>
-            <a:endParaRPr lang="en-US" sz="1300" dirty="0"/>
+            <a:endParaRPr lang="en-US" sz="1200" dirty="0"/>
           </a:p>
           <a:p>
             <a:pPr indent="0" marL="0">
               <a:spcAft>
-                <a:spcPts val="600"/>
+                <a:spcPts val="500"/>
               </a:spcAft>
               <a:buNone/>
             </a:pPr>
             <a:r>
-              <a:rPr lang="en-US" sz="1300" i="1" dirty="0">
+              <a:rPr lang="en-US" sz="1200" i="1" dirty="0">
                 <a:solidFill>
                   <a:schemeClr val="tx1"/>
                 </a:solidFill>
               </a:rPr>
               <a:t>CGDA. Fluxo do Processo de Dados – Equipe de Dados. Brasília: MEC, 2025.</a:t>
             </a:r>
-            <a:endParaRPr lang="en-US" sz="1300" dirty="0"/>
+            <a:endParaRPr lang="en-US" sz="1200" dirty="0"/>
           </a:p>
           <a:p>
             <a:pPr indent="0" marL="0">
               <a:spcAft>
-                <a:spcPts val="600"/>
+                <a:spcPts val="500"/>
               </a:spcAft>
               <a:buNone/>
             </a:pPr>
             <a:r>
-              <a:rPr lang="en-US" sz="1300" i="1" dirty="0">
+              <a:rPr lang="en-US" sz="1200" i="1" dirty="0">
                 <a:solidFill>
                   <a:schemeClr val="tx1"/>
                 </a:solidFill>
               </a:rPr>
               <a:t>CGDA. Metodologia de Dados. Brasília: MEC, 2026a.</a:t>
             </a:r>
-            <a:endParaRPr lang="en-US" sz="1300" dirty="0"/>
+            <a:endParaRPr lang="en-US" sz="1200" dirty="0"/>
           </a:p>
           <a:p>
             <a:pPr indent="0" marL="0">
               <a:spcAft>
-                <a:spcPts val="600"/>
+                <a:spcPts val="500"/>
               </a:spcAft>
               <a:buNone/>
             </a:pPr>
             <a:r>
-              <a:rPr lang="en-US" sz="1300" i="1" dirty="0">
+              <a:rPr lang="en-US" sz="1200" i="1" dirty="0">
                 <a:solidFill>
                   <a:schemeClr val="tx1"/>
                 </a:solidFill>
               </a:rPr>
               <a:t>CGDA. Pipeline para Ingestão de Dados – Landing Zone. Brasília: MEC, 2026b.</a:t>
             </a:r>
-            <a:endParaRPr lang="en-US" sz="1300" dirty="0"/>
+            <a:endParaRPr lang="en-US" sz="1200" dirty="0"/>
           </a:p>
           <a:p>
             <a:pPr indent="0" marL="0">
               <a:spcAft>
-                <a:spcPts val="600"/>
+                <a:spcPts val="500"/>
               </a:spcAft>
               <a:buNone/>
             </a:pPr>
             <a:r>
-              <a:rPr lang="en-US" sz="1300" i="1" dirty="0">
+              <a:rPr lang="en-US" sz="1200" i="1" dirty="0">
                 <a:solidFill>
                   <a:schemeClr val="tx1"/>
                 </a:solidFill>
               </a:rPr>
               <a:t>GITLAB. GitLab Documentation. Disponível em: https://docs.gitlab.com/.</a:t>
             </a:r>
-            <a:endParaRPr lang="en-US" sz="1300" dirty="0"/>
+            <a:endParaRPr lang="en-US" sz="1200" dirty="0"/>
           </a:p>
           <a:p>
             <a:pPr indent="0" marL="0">
               <a:spcAft>
-                <a:spcPts val="600"/>
+                <a:spcPts val="500"/>
               </a:spcAft>
               <a:buNone/>
             </a:pPr>
             <a:r>
-              <a:rPr lang="en-US" sz="1300" i="1" dirty="0">
+              <a:rPr lang="en-US" sz="1200" i="1" dirty="0">
                 <a:solidFill>
                   <a:schemeClr val="tx1"/>
                 </a:solidFill>
               </a:rPr>
               <a:t>KIMBALL, R.; ROSS, M. The Data Warehouse Toolkit. 3. ed. Indianapolis: Wiley, 2013.</a:t>
             </a:r>
-            <a:endParaRPr lang="en-US" sz="1300" dirty="0"/>
+            <a:endParaRPr lang="en-US" sz="1200" dirty="0"/>
           </a:p>
           <a:p>
             <a:pPr indent="0" marL="0">
               <a:spcAft>
-                <a:spcPts val="600"/>
+                <a:spcPts val="500"/>
               </a:spcAft>
               <a:buNone/>
             </a:pPr>
             <a:r>
-              <a:rPr lang="en-US" sz="1300" i="1" dirty="0">
+              <a:rPr lang="en-US" sz="1200" i="1" dirty="0">
                 <a:solidFill>
                   <a:schemeClr val="tx1"/>
                 </a:solidFill>
               </a:rPr>
               <a:t>MICROSOFT. Power BI Documentation. Disponível em: https://learn.microsoft.com/power-bi/.</a:t>
             </a:r>
-            <a:endParaRPr lang="en-US" sz="1300" dirty="0"/>
+            <a:endParaRPr lang="en-US" sz="1200" dirty="0"/>
           </a:p>
           <a:p>
             <a:pPr indent="0" marL="0">
               <a:spcAft>
-                <a:spcPts val="600"/>
+                <a:spcPts val="500"/>
               </a:spcAft>
               <a:buNone/>
             </a:pPr>
             <a:r>
-              <a:rPr lang="en-US" sz="1300" i="1" dirty="0">
+              <a:rPr lang="en-US" sz="1200" i="1" dirty="0">
                 <a:solidFill>
                   <a:schemeClr val="tx1"/>
                 </a:solidFill>
               </a:rPr>
               <a:t>ORACLE. Oracle Exadata Database Machine Documentation, 2026a; Oracle Database Documentation, 2026b.</a:t>
             </a:r>
-            <a:endParaRPr lang="en-US" sz="1300" dirty="0"/>
+            <a:endParaRPr lang="en-US" sz="1200" dirty="0"/>
           </a:p>
           <a:p>
             <a:pPr indent="0" marL="0">
               <a:spcAft>
-                <a:spcPts val="600"/>
+                <a:spcPts val="500"/>
               </a:spcAft>
               <a:buNone/>
             </a:pPr>
             <a:r>
-              <a:rPr lang="en-US" sz="1300" i="1" dirty="0">
+              <a:rPr lang="en-US" sz="1200" i="1" dirty="0">
                 <a:solidFill>
                   <a:schemeClr val="tx1"/>
                 </a:solidFill>
               </a:rPr>
               <a:t>PYTHON SOFTWARE FOUNDATION. Python Documentation. Disponível em: https://docs.python.org/3/.</a:t>
             </a:r>
-            <a:endParaRPr lang="en-US" sz="1300" dirty="0"/>
-          </a:p>
-        </p:txBody>
-      </p:sp>
-      <p:sp>
-        <p:nvSpPr>
-          <p:cNvPr id="4" name="Text 2"/>
+            <a:endParaRPr lang="en-US" sz="1200" dirty="0"/>
+          </a:p>
+        </p:txBody>
+      </p:sp>
+      <p:pic>
+        <p:nvPicPr>
+          <p:cNvPr id="4" name="Ilustração organizing-projects" descr="Ilustração: pessoa organizando documentos">    </p:cNvPr>
+          <p:cNvPicPr>
+            <a:picLocks noChangeAspect="1"/>
+          </p:cNvPicPr>
+          <p:nvPr/>
+        </p:nvPicPr>
+        <p:blipFill>
+          <a:blip r:embed="rId1"/>
+          <a:stretch>
+            <a:fillRect/>
+          </a:stretch>
+        </p:blipFill>
+        <p:spPr>
+          <a:xfrm>
+            <a:off x="8595360" y="2103120"/>
+            <a:ext cx="2834640" cy="2112250"/>
+          </a:xfrm>
+          <a:prstGeom prst="rect">
+            <a:avLst/>
+          </a:prstGeom>
+        </p:spPr>
+      </p:pic>
+      <p:sp>
+        <p:nvSpPr>
+          <p:cNvPr id="5" name="Text 2"/>
           <p:cNvSpPr txBox="1"/>
           <p:nvPr/>
         </p:nvSpPr>
@@ -11078,7 +11126,7 @@
         <p:spPr>
           <a:xfrm>
             <a:off x="1691640" y="1463040"/>
-            <a:ext cx="4389120" cy="685800"/>
+            <a:ext cx="2697480" cy="685800"/>
           </a:xfrm>
           <a:prstGeom prst="rect">
             <a:avLst/>
@@ -11094,14 +11142,14 @@
               <a:buNone/>
             </a:pPr>
             <a:r>
-              <a:rPr lang="en-US" sz="1800" i="1" dirty="0">
+              <a:rPr lang="en-US" sz="1600" i="1" dirty="0">
                 <a:solidFill>
                   <a:schemeClr val="tx1"/>
                 </a:solidFill>
               </a:rPr>
               <a:t>Introdução</a:t>
             </a:r>
-            <a:endParaRPr lang="en-US" sz="1800" dirty="0"/>
+            <a:endParaRPr lang="en-US" sz="1600" dirty="0"/>
           </a:p>
         </p:txBody>
       </p:sp>
@@ -11172,7 +11220,7 @@
         <p:spPr>
           <a:xfrm>
             <a:off x="1691640" y="2359152"/>
-            <a:ext cx="4389120" cy="685800"/>
+            <a:ext cx="2697480" cy="685800"/>
           </a:xfrm>
           <a:prstGeom prst="rect">
             <a:avLst/>
@@ -11188,14 +11236,14 @@
               <a:buNone/>
             </a:pPr>
             <a:r>
-              <a:rPr lang="en-US" sz="1800" i="1" dirty="0">
+              <a:rPr lang="en-US" sz="1600" i="1" dirty="0">
                 <a:solidFill>
                   <a:schemeClr val="tx1"/>
                 </a:solidFill>
               </a:rPr>
               <a:t>Visão geral do ecossistema de dados</a:t>
             </a:r>
-            <a:endParaRPr lang="en-US" sz="1800" dirty="0"/>
+            <a:endParaRPr lang="en-US" sz="1600" dirty="0"/>
           </a:p>
         </p:txBody>
       </p:sp>
@@ -11266,7 +11314,7 @@
         <p:spPr>
           <a:xfrm>
             <a:off x="1691640" y="3255264"/>
-            <a:ext cx="4389120" cy="685800"/>
+            <a:ext cx="2697480" cy="685800"/>
           </a:xfrm>
           <a:prstGeom prst="rect">
             <a:avLst/>
@@ -11282,14 +11330,14 @@
               <a:buNone/>
             </a:pPr>
             <a:r>
-              <a:rPr lang="en-US" sz="1800" i="1" dirty="0">
+              <a:rPr lang="en-US" sz="1600" i="1" dirty="0">
                 <a:solidFill>
                   <a:schemeClr val="tx1"/>
                 </a:solidFill>
               </a:rPr>
               <a:t>Arquitetura de dados (AS IS)</a:t>
             </a:r>
-            <a:endParaRPr lang="en-US" sz="1800" dirty="0"/>
+            <a:endParaRPr lang="en-US" sz="1600" dirty="0"/>
           </a:p>
         </p:txBody>
       </p:sp>
@@ -11360,7 +11408,7 @@
         <p:spPr>
           <a:xfrm>
             <a:off x="1691640" y="4151376"/>
-            <a:ext cx="4389120" cy="685800"/>
+            <a:ext cx="2697480" cy="685800"/>
           </a:xfrm>
           <a:prstGeom prst="rect">
             <a:avLst/>
@@ -11376,14 +11424,14 @@
               <a:buNone/>
             </a:pPr>
             <a:r>
-              <a:rPr lang="en-US" sz="1800" i="1" dirty="0">
+              <a:rPr lang="en-US" sz="1600" i="1" dirty="0">
                 <a:solidFill>
                   <a:schemeClr val="tx1"/>
                 </a:solidFill>
               </a:rPr>
               <a:t>Pipeline de ETL/ELT</a:t>
             </a:r>
-            <a:endParaRPr lang="en-US" sz="1800" dirty="0"/>
+            <a:endParaRPr lang="en-US" sz="1600" dirty="0"/>
           </a:p>
         </p:txBody>
       </p:sp>
@@ -11454,7 +11502,7 @@
         <p:spPr>
           <a:xfrm>
             <a:off x="1691640" y="5047488"/>
-            <a:ext cx="4389120" cy="685800"/>
+            <a:ext cx="2697480" cy="685800"/>
           </a:xfrm>
           <a:prstGeom prst="rect">
             <a:avLst/>
@@ -11470,14 +11518,14 @@
               <a:buNone/>
             </a:pPr>
             <a:r>
-              <a:rPr lang="en-US" sz="1800" i="1" dirty="0">
+              <a:rPr lang="en-US" sz="1600" i="1" dirty="0">
                 <a:solidFill>
                   <a:schemeClr val="tx1"/>
                 </a:solidFill>
               </a:rPr>
               <a:t>Arquitetura medalhão</a:t>
             </a:r>
-            <a:endParaRPr lang="en-US" sz="1800" dirty="0"/>
+            <a:endParaRPr lang="en-US" sz="1600" dirty="0"/>
           </a:p>
         </p:txBody>
       </p:sp>
@@ -11489,7 +11537,7 @@
         </p:nvSpPr>
         <p:spPr>
           <a:xfrm>
-            <a:off x="6309360" y="1463040"/>
+            <a:off x="4572000" y="1463040"/>
             <a:ext cx="685800" cy="685800"/>
           </a:xfrm>
           <a:prstGeom prst="roundRect">
@@ -11511,7 +11559,7 @@
         </p:nvSpPr>
         <p:spPr>
           <a:xfrm>
-            <a:off x="6309360" y="1463040"/>
+            <a:off x="4572000" y="1463040"/>
             <a:ext cx="685800" cy="685800"/>
           </a:xfrm>
           <a:prstGeom prst="rect">
@@ -11547,8 +11595,8 @@
         </p:nvSpPr>
         <p:spPr>
           <a:xfrm>
-            <a:off x="7178040" y="1463040"/>
-            <a:ext cx="4389120" cy="685800"/>
+            <a:off x="5440680" y="1463040"/>
+            <a:ext cx="2697480" cy="685800"/>
           </a:xfrm>
           <a:prstGeom prst="rect">
             <a:avLst/>
@@ -11564,14 +11612,14 @@
               <a:buNone/>
             </a:pPr>
             <a:r>
-              <a:rPr lang="en-US" sz="1800" i="1" dirty="0">
+              <a:rPr lang="en-US" sz="1600" i="1" dirty="0">
                 <a:solidFill>
                   <a:schemeClr val="tx1"/>
                 </a:solidFill>
               </a:rPr>
               <a:t>Governança de dados</a:t>
             </a:r>
-            <a:endParaRPr lang="en-US" sz="1800" dirty="0"/>
+            <a:endParaRPr lang="en-US" sz="1600" dirty="0"/>
           </a:p>
         </p:txBody>
       </p:sp>
@@ -11583,7 +11631,7 @@
         </p:nvSpPr>
         <p:spPr>
           <a:xfrm>
-            <a:off x="6309360" y="2359152"/>
+            <a:off x="4572000" y="2359152"/>
             <a:ext cx="685800" cy="685800"/>
           </a:xfrm>
           <a:prstGeom prst="roundRect">
@@ -11605,7 +11653,7 @@
         </p:nvSpPr>
         <p:spPr>
           <a:xfrm>
-            <a:off x="6309360" y="2359152"/>
+            <a:off x="4572000" y="2359152"/>
             <a:ext cx="685800" cy="685800"/>
           </a:xfrm>
           <a:prstGeom prst="rect">
@@ -11641,8 +11689,8 @@
         </p:nvSpPr>
         <p:spPr>
           <a:xfrm>
-            <a:off x="7178040" y="2359152"/>
-            <a:ext cx="4389120" cy="685800"/>
+            <a:off x="5440680" y="2359152"/>
+            <a:ext cx="2697480" cy="685800"/>
           </a:xfrm>
           <a:prstGeom prst="rect">
             <a:avLst/>
@@ -11658,14 +11706,14 @@
               <a:buNone/>
             </a:pPr>
             <a:r>
-              <a:rPr lang="en-US" sz="1800" i="1" dirty="0">
+              <a:rPr lang="en-US" sz="1600" i="1" dirty="0">
                 <a:solidFill>
                   <a:schemeClr val="tx1"/>
                 </a:solidFill>
               </a:rPr>
               <a:t>Descrição das tecnologias</a:t>
             </a:r>
-            <a:endParaRPr lang="en-US" sz="1800" dirty="0"/>
+            <a:endParaRPr lang="en-US" sz="1600" dirty="0"/>
           </a:p>
         </p:txBody>
       </p:sp>
@@ -11677,7 +11725,7 @@
         </p:nvSpPr>
         <p:spPr>
           <a:xfrm>
-            <a:off x="6309360" y="3255264"/>
+            <a:off x="4572000" y="3255264"/>
             <a:ext cx="685800" cy="685800"/>
           </a:xfrm>
           <a:prstGeom prst="roundRect">
@@ -11699,7 +11747,7 @@
         </p:nvSpPr>
         <p:spPr>
           <a:xfrm>
-            <a:off x="6309360" y="3255264"/>
+            <a:off x="4572000" y="3255264"/>
             <a:ext cx="685800" cy="685800"/>
           </a:xfrm>
           <a:prstGeom prst="rect">
@@ -11735,8 +11783,8 @@
         </p:nvSpPr>
         <p:spPr>
           <a:xfrm>
-            <a:off x="7178040" y="3255264"/>
-            <a:ext cx="4389120" cy="685800"/>
+            <a:off x="5440680" y="3255264"/>
+            <a:ext cx="2697480" cy="685800"/>
           </a:xfrm>
           <a:prstGeom prst="rect">
             <a:avLst/>
@@ -11752,14 +11800,14 @@
               <a:buNone/>
             </a:pPr>
             <a:r>
-              <a:rPr lang="en-US" sz="1800" i="1" dirty="0">
+              <a:rPr lang="en-US" sz="1600" i="1" dirty="0">
                 <a:solidFill>
                   <a:schemeClr val="tx1"/>
                 </a:solidFill>
               </a:rPr>
               <a:t>Condições atuais de acesso</a:t>
             </a:r>
-            <a:endParaRPr lang="en-US" sz="1800" dirty="0"/>
+            <a:endParaRPr lang="en-US" sz="1600" dirty="0"/>
           </a:p>
         </p:txBody>
       </p:sp>
@@ -11771,7 +11819,7 @@
         </p:nvSpPr>
         <p:spPr>
           <a:xfrm>
-            <a:off x="6309360" y="4151376"/>
+            <a:off x="4572000" y="4151376"/>
             <a:ext cx="685800" cy="685800"/>
           </a:xfrm>
           <a:prstGeom prst="roundRect">
@@ -11793,7 +11841,7 @@
         </p:nvSpPr>
         <p:spPr>
           <a:xfrm>
-            <a:off x="6309360" y="4151376"/>
+            <a:off x="4572000" y="4151376"/>
             <a:ext cx="685800" cy="685800"/>
           </a:xfrm>
           <a:prstGeom prst="rect">
@@ -11829,8 +11877,8 @@
         </p:nvSpPr>
         <p:spPr>
           <a:xfrm>
-            <a:off x="7178040" y="4151376"/>
-            <a:ext cx="4389120" cy="685800"/>
+            <a:off x="5440680" y="4151376"/>
+            <a:ext cx="2697480" cy="685800"/>
           </a:xfrm>
           <a:prstGeom prst="rect">
             <a:avLst/>
@@ -11846,17 +11894,41 @@
               <a:buNone/>
             </a:pPr>
             <a:r>
-              <a:rPr lang="en-US" sz="1800" i="1" dirty="0">
+              <a:rPr lang="en-US" sz="1600" i="1" dirty="0">
                 <a:solidFill>
                   <a:schemeClr val="tx1"/>
                 </a:solidFill>
               </a:rPr>
               <a:t>Próximos passos</a:t>
             </a:r>
-            <a:endParaRPr lang="en-US" sz="1800" dirty="0"/>
-          </a:p>
-        </p:txBody>
-      </p:sp>
+            <a:endParaRPr lang="en-US" sz="1600" dirty="0"/>
+          </a:p>
+        </p:txBody>
+      </p:sp>
+      <p:pic>
+        <p:nvPicPr>
+          <p:cNvPr id="30" name="Ilustração data-analysis" descr="Ilustração: pessoa analisando fluxo de dados">    </p:cNvPr>
+          <p:cNvPicPr>
+            <a:picLocks noChangeAspect="1"/>
+          </p:cNvPicPr>
+          <p:nvPr/>
+        </p:nvPicPr>
+        <p:blipFill>
+          <a:blip r:embed="rId1"/>
+          <a:stretch>
+            <a:fillRect/>
+          </a:stretch>
+        </p:blipFill>
+        <p:spPr>
+          <a:xfrm>
+            <a:off x="8412480" y="2103120"/>
+            <a:ext cx="3017520" cy="2083923"/>
+          </a:xfrm>
+          <a:prstGeom prst="rect">
+            <a:avLst/>
+          </a:prstGeom>
+        </p:spPr>
+      </p:pic>
       <p:sp>
         <p:nvSpPr>
           <p:cNvPr id="25" name="Slide Number Placeholder 0"/>
@@ -13857,8 +13929,8 @@
         </p:nvSpPr>
         <p:spPr>
           <a:xfrm>
-            <a:off x="822960" y="2377440"/>
-            <a:ext cx="8686800" cy="1280160"/>
+            <a:off x="822960" y="2103120"/>
+            <a:ext cx="5943600" cy="1554480"/>
           </a:xfrm>
           <a:prstGeom prst="rect">
             <a:avLst/>
@@ -13896,7 +13968,7 @@
         <p:spPr>
           <a:xfrm>
             <a:off x="822960" y="3749040"/>
-            <a:ext cx="8686800" cy="914400"/>
+            <a:ext cx="5943600" cy="914400"/>
           </a:xfrm>
           <a:prstGeom prst="rect">
             <a:avLst/>
@@ -13923,6 +13995,50 @@
           </a:p>
         </p:txBody>
       </p:sp>
+      <p:sp>
+        <p:nvSpPr>
+          <p:cNvPr id="4" name="Círculo ilustração"/>
+          <p:cNvSpPr/>
+          <p:nvPr/>
+        </p:nvSpPr>
+        <p:spPr>
+          <a:xfrm>
+            <a:off x="7086600" y="1417320"/>
+            <a:ext cx="3017520" cy="3017520"/>
+          </a:xfrm>
+          <a:prstGeom prst="ellipse">
+            <a:avLst/>
+          </a:prstGeom>
+          <a:solidFill>
+            <a:schemeClr val="bg1"/>
+          </a:solidFill>
+          <a:ln/>
+        </p:spPr>
+      </p:sp>
+      <p:pic>
+        <p:nvPicPr>
+          <p:cNvPr id="5" name="Ilustração server-cluster" descr="Ilustração: cluster de servidores">    </p:cNvPr>
+          <p:cNvPicPr>
+            <a:picLocks noChangeAspect="1"/>
+          </p:cNvPicPr>
+          <p:nvPr/>
+        </p:nvPicPr>
+        <p:blipFill>
+          <a:blip r:embed="rId1"/>
+          <a:stretch>
+            <a:fillRect/>
+          </a:stretch>
+        </p:blipFill>
+        <p:spPr>
+          <a:xfrm>
+            <a:off x="7589520" y="1920240"/>
+            <a:ext cx="2011680" cy="1610633"/>
+          </a:xfrm>
+          <a:prstGeom prst="rect">
+            <a:avLst/>
+          </a:prstGeom>
+        </p:spPr>
+      </p:pic>
     </p:spTree>
   </p:cSld>
   <p:clrMapOvr>
@@ -14038,17 +14154,17 @@
         </p:nvGraphicFramePr>
         <p:xfrm>
           <a:off x="822960" y="2103120"/>
-          <a:ext cx="10607040" cy="914400"/>
+          <a:ext cx="7680960" cy="914400"/>
         </p:xfrm>
         <a:graphic>
           <a:graphicData uri="http://schemas.openxmlformats.org/drawingml/2006/table">
             <a:tbl>
               <a:tblPr/>
               <a:tblGrid>
-                <a:gridCol w="3108960"/>
-                <a:gridCol w="1097280"/>
-                <a:gridCol w="3657600"/>
-                <a:gridCol w="2743200"/>
+                <a:gridCol w="2331720"/>
+                <a:gridCol w="731520"/>
+                <a:gridCol w="2880360"/>
+                <a:gridCol w="1737360"/>
               </a:tblGrid>
               <a:tr h="603504">
                 <a:tc>
@@ -14060,14 +14176,14 @@
                         <a:buNone/>
                       </a:pPr>
                       <a:r>
-                        <a:rPr lang="en-US" sz="1500" b="1" dirty="0">
+                        <a:rPr lang="en-US" sz="1300" b="1" dirty="0">
                           <a:solidFill>
                             <a:schemeClr val="bg1"/>
                           </a:solidFill>
                         </a:rPr>
                         <a:t>Server</a:t>
                       </a:r>
-                      <a:endParaRPr lang="en-US" sz="1500" dirty="0"/>
+                      <a:endParaRPr lang="en-US" sz="1300" dirty="0"/>
                     </a:p>
                   </a:txBody>
                   <a:tcPr marL="137160" marR="137160" marT="0" marB="0" anchor="ctr">
@@ -14121,14 +14237,14 @@
                         <a:buNone/>
                       </a:pPr>
                       <a:r>
-                        <a:rPr lang="en-US" sz="1500" b="1" dirty="0">
+                        <a:rPr lang="en-US" sz="1300" b="1" dirty="0">
                           <a:solidFill>
                             <a:schemeClr val="bg1"/>
                           </a:solidFill>
                         </a:rPr>
                         <a:t>Porta</a:t>
                       </a:r>
-                      <a:endParaRPr lang="en-US" sz="1500" dirty="0"/>
+                      <a:endParaRPr lang="en-US" sz="1300" dirty="0"/>
                     </a:p>
                   </a:txBody>
                   <a:tcPr marL="137160" marR="137160" marT="0" marB="0" anchor="ctr">
@@ -14182,14 +14298,14 @@
                         <a:buNone/>
                       </a:pPr>
                       <a:r>
-                        <a:rPr lang="en-US" sz="1500" b="1" dirty="0">
+                        <a:rPr lang="en-US" sz="1300" b="1" dirty="0">
                           <a:solidFill>
                             <a:schemeClr val="bg1"/>
                           </a:solidFill>
                         </a:rPr>
                         <a:t>Database</a:t>
                       </a:r>
-                      <a:endParaRPr lang="en-US" sz="1500" dirty="0"/>
+                      <a:endParaRPr lang="en-US" sz="1300" dirty="0"/>
                     </a:p>
                   </a:txBody>
                   <a:tcPr marL="137160" marR="137160" marT="0" marB="0" anchor="ctr">
@@ -14243,14 +14359,14 @@
                         <a:buNone/>
                       </a:pPr>
                       <a:r>
-                        <a:rPr lang="en-US" sz="1500" b="1" dirty="0">
+                        <a:rPr lang="en-US" sz="1300" b="1" dirty="0">
                           <a:solidFill>
                             <a:schemeClr val="bg1"/>
                           </a:solidFill>
                         </a:rPr>
                         <a:t>Ambiente</a:t>
                       </a:r>
-                      <a:endParaRPr lang="en-US" sz="1500" dirty="0"/>
+                      <a:endParaRPr lang="en-US" sz="1300" dirty="0"/>
                     </a:p>
                   </a:txBody>
                   <a:tcPr marL="137160" marR="137160" marT="0" marB="0" anchor="ctr">
@@ -14306,14 +14422,14 @@
                         <a:buNone/>
                       </a:pPr>
                       <a:r>
-                        <a:rPr lang="en-US" sz="1500" dirty="0">
+                        <a:rPr lang="en-US" sz="1300" dirty="0">
                           <a:solidFill>
                             <a:schemeClr val="tx1"/>
                           </a:solidFill>
                         </a:rPr>
                         <a:t>exacc3scan.mec.gov.br</a:t>
                       </a:r>
-                      <a:endParaRPr lang="en-US" sz="1500" dirty="0"/>
+                      <a:endParaRPr lang="en-US" sz="1300" dirty="0"/>
                     </a:p>
                   </a:txBody>
                   <a:tcPr marL="137160" marR="137160" marT="0" marB="0" anchor="ctr">
@@ -14364,14 +14480,14 @@
                         <a:buNone/>
                       </a:pPr>
                       <a:r>
-                        <a:rPr lang="en-US" sz="1500" dirty="0">
+                        <a:rPr lang="en-US" sz="1300" dirty="0">
                           <a:solidFill>
                             <a:schemeClr val="tx1"/>
                           </a:solidFill>
                         </a:rPr>
                         <a:t>1521</a:t>
                       </a:r>
-                      <a:endParaRPr lang="en-US" sz="1500" dirty="0"/>
+                      <a:endParaRPr lang="en-US" sz="1300" dirty="0"/>
                     </a:p>
                   </a:txBody>
                   <a:tcPr marL="137160" marR="137160" marT="0" marB="0" anchor="ctr">
@@ -14422,14 +14538,14 @@
                         <a:buNone/>
                       </a:pPr>
                       <a:r>
-                        <a:rPr lang="en-US" sz="1500" dirty="0">
+                        <a:rPr lang="en-US" sz="1300" dirty="0">
                           <a:solidFill>
                             <a:schemeClr val="tx1"/>
                           </a:solidFill>
                         </a:rPr>
                         <a:t>PDBDSV_DW.mec.gov.br</a:t>
                       </a:r>
-                      <a:endParaRPr lang="en-US" sz="1500" dirty="0"/>
+                      <a:endParaRPr lang="en-US" sz="1300" dirty="0"/>
                     </a:p>
                   </a:txBody>
                   <a:tcPr marL="137160" marR="137160" marT="0" marB="0" anchor="ctr">
@@ -14480,14 +14596,14 @@
                         <a:buNone/>
                       </a:pPr>
                       <a:r>
-                        <a:rPr lang="en-US" sz="1500" b="1" dirty="0">
+                        <a:rPr lang="en-US" sz="1300" b="1" dirty="0">
                           <a:solidFill>
                             <a:schemeClr val="bg1"/>
                           </a:solidFill>
                         </a:rPr>
                         <a:t>Desenvolvimento</a:t>
                       </a:r>
-                      <a:endParaRPr lang="en-US" sz="1500" dirty="0"/>
+                      <a:endParaRPr lang="en-US" sz="1300" dirty="0"/>
                     </a:p>
                   </a:txBody>
                   <a:tcPr marL="137160" marR="137160" marT="0" marB="0" anchor="ctr">
@@ -14543,14 +14659,14 @@
                         <a:buNone/>
                       </a:pPr>
                       <a:r>
-                        <a:rPr lang="en-US" sz="1500" dirty="0">
+                        <a:rPr lang="en-US" sz="1300" dirty="0">
                           <a:solidFill>
                             <a:schemeClr val="tx1"/>
                           </a:solidFill>
                         </a:rPr>
                         <a:t>exacc3scan.mec.gov.br</a:t>
                       </a:r>
-                      <a:endParaRPr lang="en-US" sz="1500" dirty="0"/>
+                      <a:endParaRPr lang="en-US" sz="1300" dirty="0"/>
                     </a:p>
                   </a:txBody>
                   <a:tcPr marL="137160" marR="137160" marT="0" marB="0" anchor="ctr">
@@ -14601,14 +14717,14 @@
                         <a:buNone/>
                       </a:pPr>
                       <a:r>
-                        <a:rPr lang="en-US" sz="1500" dirty="0">
+                        <a:rPr lang="en-US" sz="1300" dirty="0">
                           <a:solidFill>
                             <a:schemeClr val="tx1"/>
                           </a:solidFill>
                         </a:rPr>
                         <a:t>1521</a:t>
                       </a:r>
-                      <a:endParaRPr lang="en-US" sz="1500" dirty="0"/>
+                      <a:endParaRPr lang="en-US" sz="1300" dirty="0"/>
                     </a:p>
                   </a:txBody>
                   <a:tcPr marL="137160" marR="137160" marT="0" marB="0" anchor="ctr">
@@ -14659,14 +14775,14 @@
                         <a:buNone/>
                       </a:pPr>
                       <a:r>
-                        <a:rPr lang="en-US" sz="1500" dirty="0">
+                        <a:rPr lang="en-US" sz="1300" dirty="0">
                           <a:solidFill>
                             <a:schemeClr val="tx1"/>
                           </a:solidFill>
                         </a:rPr>
                         <a:t>PDBHMG_DW.mec.gov.br</a:t>
                       </a:r>
-                      <a:endParaRPr lang="en-US" sz="1500" dirty="0"/>
+                      <a:endParaRPr lang="en-US" sz="1300" dirty="0"/>
                     </a:p>
                   </a:txBody>
                   <a:tcPr marL="137160" marR="137160" marT="0" marB="0" anchor="ctr">
@@ -14717,14 +14833,14 @@
                         <a:buNone/>
                       </a:pPr>
                       <a:r>
-                        <a:rPr lang="en-US" sz="1500" b="1" dirty="0">
+                        <a:rPr lang="en-US" sz="1300" b="1" dirty="0">
                           <a:solidFill>
                             <a:schemeClr val="tx1"/>
                           </a:solidFill>
                         </a:rPr>
                         <a:t>Homologação</a:t>
                       </a:r>
-                      <a:endParaRPr lang="en-US" sz="1500" dirty="0"/>
+                      <a:endParaRPr lang="en-US" sz="1300" dirty="0"/>
                     </a:p>
                   </a:txBody>
                   <a:tcPr marL="137160" marR="137160" marT="0" marB="0" anchor="ctr">
@@ -14780,14 +14896,14 @@
                         <a:buNone/>
                       </a:pPr>
                       <a:r>
-                        <a:rPr lang="en-US" sz="1500" dirty="0">
+                        <a:rPr lang="en-US" sz="1300" dirty="0">
                           <a:solidFill>
                             <a:schemeClr val="tx1"/>
                           </a:solidFill>
                         </a:rPr>
                         <a:t>exacc2-scan.mec.gov.br</a:t>
                       </a:r>
-                      <a:endParaRPr lang="en-US" sz="1500" dirty="0"/>
+                      <a:endParaRPr lang="en-US" sz="1300" dirty="0"/>
                     </a:p>
                   </a:txBody>
                   <a:tcPr marL="137160" marR="137160" marT="0" marB="0" anchor="ctr">
@@ -14838,14 +14954,14 @@
                         <a:buNone/>
                       </a:pPr>
                       <a:r>
-                        <a:rPr lang="en-US" sz="1500" dirty="0">
+                        <a:rPr lang="en-US" sz="1300" dirty="0">
                           <a:solidFill>
                             <a:schemeClr val="tx1"/>
                           </a:solidFill>
                         </a:rPr>
                         <a:t>1521</a:t>
                       </a:r>
-                      <a:endParaRPr lang="en-US" sz="1500" dirty="0"/>
+                      <a:endParaRPr lang="en-US" sz="1300" dirty="0"/>
                     </a:p>
                   </a:txBody>
                   <a:tcPr marL="137160" marR="137160" marT="0" marB="0" anchor="ctr">
@@ -14896,14 +15012,14 @@
                         <a:buNone/>
                       </a:pPr>
                       <a:r>
-                        <a:rPr lang="en-US" sz="1500" dirty="0">
+                        <a:rPr lang="en-US" sz="1300" dirty="0">
                           <a:solidFill>
                             <a:schemeClr val="tx1"/>
                           </a:solidFill>
                         </a:rPr>
                         <a:t>PDBPRD_DW.mec.gov.br</a:t>
                       </a:r>
-                      <a:endParaRPr lang="en-US" sz="1500" dirty="0"/>
+                      <a:endParaRPr lang="en-US" sz="1300" dirty="0"/>
                     </a:p>
                   </a:txBody>
                   <a:tcPr marL="137160" marR="137160" marT="0" marB="0" anchor="ctr">
@@ -14954,14 +15070,14 @@
                         <a:buNone/>
                       </a:pPr>
                       <a:r>
-                        <a:rPr lang="en-US" sz="1500" b="1" dirty="0">
+                        <a:rPr lang="en-US" sz="1300" b="1" dirty="0">
                           <a:solidFill>
                             <a:schemeClr val="tx1"/>
                           </a:solidFill>
                         </a:rPr>
                         <a:t>Produção</a:t>
                       </a:r>
-                      <a:endParaRPr lang="en-US" sz="1500" dirty="0"/>
+                      <a:endParaRPr lang="en-US" sz="1300" dirty="0"/>
                     </a:p>
                   </a:txBody>
                   <a:tcPr marL="137160" marR="137160" marT="0" marB="0" anchor="ctr">
@@ -15017,14 +15133,14 @@
                         <a:buNone/>
                       </a:pPr>
                       <a:r>
-                        <a:rPr lang="en-US" sz="1500" dirty="0">
+                        <a:rPr lang="en-US" sz="1300" dirty="0">
                           <a:solidFill>
                             <a:schemeClr val="tx1"/>
                           </a:solidFill>
                         </a:rPr>
                         <a:t>exacc2-scan.mec.gov.br</a:t>
                       </a:r>
-                      <a:endParaRPr lang="en-US" sz="1500" dirty="0"/>
+                      <a:endParaRPr lang="en-US" sz="1300" dirty="0"/>
                     </a:p>
                   </a:txBody>
                   <a:tcPr marL="137160" marR="137160" marT="0" marB="0" anchor="ctr">
@@ -15075,14 +15191,14 @@
                         <a:buNone/>
                       </a:pPr>
                       <a:r>
-                        <a:rPr lang="en-US" sz="1500" dirty="0">
+                        <a:rPr lang="en-US" sz="1300" dirty="0">
                           <a:solidFill>
                             <a:schemeClr val="tx1"/>
                           </a:solidFill>
                         </a:rPr>
                         <a:t>1521</a:t>
                       </a:r>
-                      <a:endParaRPr lang="en-US" sz="1500" dirty="0"/>
+                      <a:endParaRPr lang="en-US" sz="1300" dirty="0"/>
                     </a:p>
                   </a:txBody>
                   <a:tcPr marL="137160" marR="137160" marT="0" marB="0" anchor="ctr">
@@ -15133,14 +15249,14 @@
                         <a:buNone/>
                       </a:pPr>
                       <a:r>
-                        <a:rPr lang="en-US" sz="1500" dirty="0">
+                        <a:rPr lang="en-US" sz="1300" dirty="0">
                           <a:solidFill>
                             <a:schemeClr val="tx1"/>
                           </a:solidFill>
                         </a:rPr>
                         <a:t>PDBPRD_STGDW.mec.gov.br</a:t>
                       </a:r>
-                      <a:endParaRPr lang="en-US" sz="1500" dirty="0"/>
+                      <a:endParaRPr lang="en-US" sz="1300" dirty="0"/>
                     </a:p>
                   </a:txBody>
                   <a:tcPr marL="137160" marR="137160" marT="0" marB="0" anchor="ctr">
@@ -15191,14 +15307,14 @@
                         <a:buNone/>
                       </a:pPr>
                       <a:r>
-                        <a:rPr lang="en-US" sz="1500" b="1" dirty="0">
+                        <a:rPr lang="en-US" sz="1300" b="1" dirty="0">
                           <a:solidFill>
                             <a:schemeClr val="bg1"/>
                           </a:solidFill>
                         </a:rPr>
                         <a:t>Stage</a:t>
                       </a:r>
-                      <a:endParaRPr lang="en-US" sz="1500" dirty="0"/>
+                      <a:endParaRPr lang="en-US" sz="1300" dirty="0"/>
                     </a:p>
                   </a:txBody>
                   <a:tcPr marL="137160" marR="137160" marT="0" marB="0" anchor="ctr">
@@ -15248,15 +15364,39 @@
           </a:graphicData>
         </a:graphic>
       </p:graphicFrame>
-      <p:sp>
-        <p:nvSpPr>
-          <p:cNvPr id="5" name="Text 2"/>
+      <p:pic>
+        <p:nvPicPr>
+          <p:cNvPr id="5" name="Ilustração server" descr="Ilustração: pessoa ao lado de servidores">    </p:cNvPr>
+          <p:cNvPicPr>
+            <a:picLocks noChangeAspect="1"/>
+          </p:cNvPicPr>
+          <p:nvPr/>
+        </p:nvPicPr>
+        <p:blipFill>
+          <a:blip r:embed="rId1"/>
+          <a:stretch>
+            <a:fillRect/>
+          </a:stretch>
+        </p:blipFill>
+        <p:spPr>
+          <a:xfrm>
+            <a:off x="8778240" y="2514600"/>
+            <a:ext cx="2651760" cy="1753810"/>
+          </a:xfrm>
+          <a:prstGeom prst="rect">
+            <a:avLst/>
+          </a:prstGeom>
+        </p:spPr>
+      </p:pic>
+      <p:sp>
+        <p:nvSpPr>
+          <p:cNvPr id="6" name="Text 2"/>
           <p:cNvSpPr txBox="1"/>
           <p:nvPr/>
         </p:nvSpPr>
         <p:spPr>
           <a:xfrm>
-            <a:off x="822960" y="5074920"/>
+            <a:off x="822960" y="5257800"/>
             <a:ext cx="10607040" cy="320040"/>
           </a:xfrm>
           <a:prstGeom prst="rect">

</xml_diff>